<commit_message>
fixed and added day/night to architecture
</commit_message>
<xml_diff>
--- a/architecture.pptx
+++ b/architecture.pptx
@@ -108,6 +108,11 @@
       </a:defRPr>
     </a:lvl9pPr>
   </p:defaultTextStyle>
+  <p:extLst>
+    <p:ext uri="{EFAFB233-063F-42B5-8137-9DF3F51BA10A}">
+      <p15:sldGuideLst xmlns:p15="http://schemas.microsoft.com/office/powerpoint/2012/main"/>
+    </p:ext>
+  </p:extLst>
 </p:presentation>
 </file>
 
@@ -193,7 +198,7 @@
           <a:p>
             <a:fld id="{5C47702D-6B6D-43A5-8DDF-5B09FC13538F}" type="datetimeFigureOut">
               <a:rPr lang="en-US" smtClean="0"/>
-              <a:t>8/4/2026</a:t>
+              <a:t>8/6/2026</a:t>
             </a:fld>
             <a:endParaRPr lang="en-US"/>
           </a:p>
@@ -691,7 +696,7 @@
           <a:p>
             <a:fld id="{A1089E45-F761-4DAB-AAC7-0546A49BFEE2}" type="datetimeFigureOut">
               <a:rPr lang="en-US" smtClean="0"/>
-              <a:t>8/4/2026</a:t>
+              <a:t>8/6/2026</a:t>
             </a:fld>
             <a:endParaRPr lang="en-US"/>
           </a:p>
@@ -889,7 +894,7 @@
           <a:p>
             <a:fld id="{A1089E45-F761-4DAB-AAC7-0546A49BFEE2}" type="datetimeFigureOut">
               <a:rPr lang="en-US" smtClean="0"/>
-              <a:t>8/4/2026</a:t>
+              <a:t>8/6/2026</a:t>
             </a:fld>
             <a:endParaRPr lang="en-US"/>
           </a:p>
@@ -1097,7 +1102,7 @@
           <a:p>
             <a:fld id="{A1089E45-F761-4DAB-AAC7-0546A49BFEE2}" type="datetimeFigureOut">
               <a:rPr lang="en-US" smtClean="0"/>
-              <a:t>8/4/2026</a:t>
+              <a:t>8/6/2026</a:t>
             </a:fld>
             <a:endParaRPr lang="en-US"/>
           </a:p>
@@ -1295,7 +1300,7 @@
           <a:p>
             <a:fld id="{A1089E45-F761-4DAB-AAC7-0546A49BFEE2}" type="datetimeFigureOut">
               <a:rPr lang="en-US" smtClean="0"/>
-              <a:t>8/4/2026</a:t>
+              <a:t>8/6/2026</a:t>
             </a:fld>
             <a:endParaRPr lang="en-US"/>
           </a:p>
@@ -1570,7 +1575,7 @@
           <a:p>
             <a:fld id="{A1089E45-F761-4DAB-AAC7-0546A49BFEE2}" type="datetimeFigureOut">
               <a:rPr lang="en-US" smtClean="0"/>
-              <a:t>8/4/2026</a:t>
+              <a:t>8/6/2026</a:t>
             </a:fld>
             <a:endParaRPr lang="en-US"/>
           </a:p>
@@ -1835,7 +1840,7 @@
           <a:p>
             <a:fld id="{A1089E45-F761-4DAB-AAC7-0546A49BFEE2}" type="datetimeFigureOut">
               <a:rPr lang="en-US" smtClean="0"/>
-              <a:t>8/4/2026</a:t>
+              <a:t>8/6/2026</a:t>
             </a:fld>
             <a:endParaRPr lang="en-US"/>
           </a:p>
@@ -2247,7 +2252,7 @@
           <a:p>
             <a:fld id="{A1089E45-F761-4DAB-AAC7-0546A49BFEE2}" type="datetimeFigureOut">
               <a:rPr lang="en-US" smtClean="0"/>
-              <a:t>8/4/2026</a:t>
+              <a:t>8/6/2026</a:t>
             </a:fld>
             <a:endParaRPr lang="en-US"/>
           </a:p>
@@ -2388,7 +2393,7 @@
           <a:p>
             <a:fld id="{A1089E45-F761-4DAB-AAC7-0546A49BFEE2}" type="datetimeFigureOut">
               <a:rPr lang="en-US" smtClean="0"/>
-              <a:t>8/4/2026</a:t>
+              <a:t>8/6/2026</a:t>
             </a:fld>
             <a:endParaRPr lang="en-US"/>
           </a:p>
@@ -2501,7 +2506,7 @@
           <a:p>
             <a:fld id="{A1089E45-F761-4DAB-AAC7-0546A49BFEE2}" type="datetimeFigureOut">
               <a:rPr lang="en-US" smtClean="0"/>
-              <a:t>8/4/2026</a:t>
+              <a:t>8/6/2026</a:t>
             </a:fld>
             <a:endParaRPr lang="en-US"/>
           </a:p>
@@ -2812,7 +2817,7 @@
           <a:p>
             <a:fld id="{A1089E45-F761-4DAB-AAC7-0546A49BFEE2}" type="datetimeFigureOut">
               <a:rPr lang="en-US" smtClean="0"/>
-              <a:t>8/4/2026</a:t>
+              <a:t>8/6/2026</a:t>
             </a:fld>
             <a:endParaRPr lang="en-US"/>
           </a:p>
@@ -3100,7 +3105,7 @@
           <a:p>
             <a:fld id="{A1089E45-F761-4DAB-AAC7-0546A49BFEE2}" type="datetimeFigureOut">
               <a:rPr lang="en-US" smtClean="0"/>
-              <a:t>8/4/2026</a:t>
+              <a:t>8/6/2026</a:t>
             </a:fld>
             <a:endParaRPr lang="en-US"/>
           </a:p>
@@ -3341,7 +3346,7 @@
           <a:p>
             <a:fld id="{A1089E45-F761-4DAB-AAC7-0546A49BFEE2}" type="datetimeFigureOut">
               <a:rPr lang="en-US" smtClean="0"/>
-              <a:t>8/4/2026</a:t>
+              <a:t>8/6/2026</a:t>
             </a:fld>
             <a:endParaRPr lang="en-US"/>
           </a:p>
@@ -4911,7 +4916,7 @@
         </p:nvSpPr>
         <p:spPr>
           <a:xfrm>
-            <a:off x="7139257" y="4562804"/>
+            <a:off x="7139257" y="4182929"/>
             <a:ext cx="914400" cy="279395"/>
           </a:xfrm>
           <a:prstGeom prst="roundRect">
@@ -6100,7 +6105,7 @@
         <p:spPr>
           <a:xfrm>
             <a:off x="4030132" y="3571534"/>
-            <a:ext cx="3109125" cy="1130968"/>
+            <a:ext cx="3109125" cy="751093"/>
           </a:xfrm>
           <a:prstGeom prst="bentConnector3">
             <a:avLst>
@@ -6197,6 +6202,102 @@
           <a:xfrm rot="16200000" flipH="1">
             <a:off x="1303111" y="5582526"/>
             <a:ext cx="359033" cy="522405"/>
+          </a:xfrm>
+          <a:prstGeom prst="bentConnector3">
+            <a:avLst>
+              <a:gd name="adj1" fmla="val 50000"/>
+            </a:avLst>
+          </a:prstGeom>
+          <a:ln>
+            <a:headEnd type="triangle"/>
+            <a:tailEnd type="triangle"/>
+          </a:ln>
+        </p:spPr>
+        <p:style>
+          <a:lnRef idx="2">
+            <a:schemeClr val="accent1"/>
+          </a:lnRef>
+          <a:fillRef idx="0">
+            <a:schemeClr val="accent1"/>
+          </a:fillRef>
+          <a:effectRef idx="1">
+            <a:schemeClr val="accent1"/>
+          </a:effectRef>
+          <a:fontRef idx="minor">
+            <a:schemeClr val="tx1"/>
+          </a:fontRef>
+        </p:style>
+      </p:cxnSp>
+      <p:sp>
+        <p:nvSpPr>
+          <p:cNvPr id="3" name="Rectangle: Rounded Corners 2">
+            <a:extLst>
+              <a:ext uri="{FF2B5EF4-FFF2-40B4-BE49-F238E27FC236}">
+                <a16:creationId xmlns:a16="http://schemas.microsoft.com/office/drawing/2014/main" id="{DC05B7C0-8D9C-8211-882C-91F09C53F482}"/>
+              </a:ext>
+            </a:extLst>
+          </p:cNvPr>
+          <p:cNvSpPr/>
+          <p:nvPr/>
+        </p:nvSpPr>
+        <p:spPr>
+          <a:xfrm>
+            <a:off x="7139257" y="4605151"/>
+            <a:ext cx="914400" cy="279395"/>
+          </a:xfrm>
+          <a:prstGeom prst="roundRect">
+            <a:avLst/>
+          </a:prstGeom>
+        </p:spPr>
+        <p:style>
+          <a:lnRef idx="2">
+            <a:schemeClr val="accent1">
+              <a:shade val="15000"/>
+            </a:schemeClr>
+          </a:lnRef>
+          <a:fillRef idx="1">
+            <a:schemeClr val="accent1"/>
+          </a:fillRef>
+          <a:effectRef idx="0">
+            <a:schemeClr val="accent1"/>
+          </a:effectRef>
+          <a:fontRef idx="minor">
+            <a:schemeClr val="lt1"/>
+          </a:fontRef>
+        </p:style>
+        <p:txBody>
+          <a:bodyPr rtlCol="0" anchor="ctr"/>
+          <a:lstStyle/>
+          <a:p>
+            <a:pPr algn="ctr"/>
+            <a:r>
+              <a:rPr lang="en-US" sz="1100" dirty="0"/>
+              <a:t>Day/Night</a:t>
+            </a:r>
+            <a:endParaRPr lang="en-US" dirty="0"/>
+          </a:p>
+        </p:txBody>
+      </p:sp>
+      <p:cxnSp>
+        <p:nvCxnSpPr>
+          <p:cNvPr id="5" name="Straight Arrow Connector 137">
+            <a:extLst>
+              <a:ext uri="{FF2B5EF4-FFF2-40B4-BE49-F238E27FC236}">
+                <a16:creationId xmlns:a16="http://schemas.microsoft.com/office/drawing/2014/main" id="{2BAA068C-BE48-B1BD-D2AF-17A6098B7766}"/>
+              </a:ext>
+            </a:extLst>
+          </p:cNvPr>
+          <p:cNvCxnSpPr>
+            <a:cxnSpLocks/>
+            <a:stCxn id="58" idx="3"/>
+            <a:endCxn id="3" idx="1"/>
+          </p:cNvCxnSpPr>
+          <p:nvPr/>
+        </p:nvCxnSpPr>
+        <p:spPr>
+          <a:xfrm>
+            <a:off x="4030132" y="3571534"/>
+            <a:ext cx="3109125" cy="1173315"/>
           </a:xfrm>
           <a:prstGeom prst="bentConnector3">
             <a:avLst>

</xml_diff>